<commit_message>
Move pipeline connecting line above description text to prevent overlap
Made-with: Cursor
</commit_message>
<xml_diff>
--- a/CertOps_Studio_Demo_Day.pptx
+++ b/CertOps_Studio_Demo_Day.pptx
@@ -136,7 +136,7 @@
   <pc:docChgLst>
     <pc:chgData name="Joseph Mata" userId="7bc4e0a3-43fe-410e-ab0b-dd6ac2ed59a7" providerId="ADAL" clId="{20AA238B-BA4D-59F0-BE88-0BD221C4FFE9}"/>
     <pc:docChg chg="undo custSel mod addSld delSld modSld sldOrd">
-      <pc:chgData name="Joseph Mata" userId="7bc4e0a3-43fe-410e-ab0b-dd6ac2ed59a7" providerId="ADAL" clId="{20AA238B-BA4D-59F0-BE88-0BD221C4FFE9}" dt="2026-03-19T02:45:41.395" v="5148" actId="20577"/>
+      <pc:chgData name="Joseph Mata" userId="7bc4e0a3-43fe-410e-ab0b-dd6ac2ed59a7" providerId="ADAL" clId="{20AA238B-BA4D-59F0-BE88-0BD221C4FFE9}" dt="2026-03-19T03:05:39.221" v="5193" actId="478"/>
       <pc:docMkLst>
         <pc:docMk/>
       </pc:docMkLst>
@@ -210,7 +210,7 @@
         </pc:sldMkLst>
       </pc:sldChg>
       <pc:sldChg chg="addSp delSp modSp add mod setBg delAnim modAnim">
-        <pc:chgData name="Joseph Mata" userId="7bc4e0a3-43fe-410e-ab0b-dd6ac2ed59a7" providerId="ADAL" clId="{20AA238B-BA4D-59F0-BE88-0BD221C4FFE9}" dt="2026-03-18T03:57:24.033" v="2687" actId="14100"/>
+        <pc:chgData name="Joseph Mata" userId="7bc4e0a3-43fe-410e-ab0b-dd6ac2ed59a7" providerId="ADAL" clId="{20AA238B-BA4D-59F0-BE88-0BD221C4FFE9}" dt="2026-03-19T03:05:29.745" v="5190" actId="478"/>
         <pc:sldMkLst>
           <pc:docMk/>
           <pc:sldMk cId="4148440160" sldId="268"/>
@@ -223,16 +223,16 @@
             <ac:picMk id="8" creationId="{D13EDA46-1535-4F57-15B1-8131E6B1EE5B}"/>
           </ac:picMkLst>
         </pc:picChg>
-        <pc:picChg chg="add mod">
-          <ac:chgData name="Joseph Mata" userId="7bc4e0a3-43fe-410e-ab0b-dd6ac2ed59a7" providerId="ADAL" clId="{20AA238B-BA4D-59F0-BE88-0BD221C4FFE9}" dt="2026-03-17T22:38:56.781" v="2037"/>
+        <pc:picChg chg="add del mod">
+          <ac:chgData name="Joseph Mata" userId="7bc4e0a3-43fe-410e-ab0b-dd6ac2ed59a7" providerId="ADAL" clId="{20AA238B-BA4D-59F0-BE88-0BD221C4FFE9}" dt="2026-03-19T03:05:29.745" v="5190" actId="478"/>
           <ac:picMkLst>
             <pc:docMk/>
             <pc:sldMk cId="4148440160" sldId="268"/>
             <ac:picMk id="10" creationId="{AD8DF6D9-9172-4468-9FBC-D9A62497CC86}"/>
           </ac:picMkLst>
         </pc:picChg>
-        <pc:picChg chg="add mod modCrop">
-          <ac:chgData name="Joseph Mata" userId="7bc4e0a3-43fe-410e-ab0b-dd6ac2ed59a7" providerId="ADAL" clId="{20AA238B-BA4D-59F0-BE88-0BD221C4FFE9}" dt="2026-03-18T03:57:24.033" v="2687" actId="14100"/>
+        <pc:picChg chg="add del mod modCrop">
+          <ac:chgData name="Joseph Mata" userId="7bc4e0a3-43fe-410e-ab0b-dd6ac2ed59a7" providerId="ADAL" clId="{20AA238B-BA4D-59F0-BE88-0BD221C4FFE9}" dt="2026-03-19T03:05:28.205" v="5189" actId="478"/>
           <ac:picMkLst>
             <pc:docMk/>
             <pc:sldMk cId="4148440160" sldId="268"/>
@@ -312,7 +312,7 @@
         </pc:picChg>
       </pc:sldChg>
       <pc:sldChg chg="addSp delSp modSp add mod modAnim modNotesTx">
-        <pc:chgData name="Joseph Mata" userId="7bc4e0a3-43fe-410e-ab0b-dd6ac2ed59a7" providerId="ADAL" clId="{20AA238B-BA4D-59F0-BE88-0BD221C4FFE9}" dt="2026-03-19T02:45:41.395" v="5148" actId="20577"/>
+        <pc:chgData name="Joseph Mata" userId="7bc4e0a3-43fe-410e-ab0b-dd6ac2ed59a7" providerId="ADAL" clId="{20AA238B-BA4D-59F0-BE88-0BD221C4FFE9}" dt="2026-03-19T02:53:56.116" v="5188" actId="20577"/>
         <pc:sldMkLst>
           <pc:docMk/>
           <pc:sldMk cId="229041283" sldId="2147483418"/>
@@ -967,7 +967,7 @@
         </pc:cxnChg>
       </pc:sldChg>
       <pc:sldChg chg="add ord modNotesTx">
-        <pc:chgData name="Joseph Mata" userId="7bc4e0a3-43fe-410e-ab0b-dd6ac2ed59a7" providerId="ADAL" clId="{20AA238B-BA4D-59F0-BE88-0BD221C4FFE9}" dt="2026-03-19T00:50:52.299" v="2908" actId="20577"/>
+        <pc:chgData name="Joseph Mata" userId="7bc4e0a3-43fe-410e-ab0b-dd6ac2ed59a7" providerId="ADAL" clId="{20AA238B-BA4D-59F0-BE88-0BD221C4FFE9}" dt="2026-03-19T02:49:05.847" v="5173" actId="20577"/>
         <pc:sldMkLst>
           <pc:docMk/>
           <pc:sldMk cId="468562430" sldId="2147483422"/>
@@ -1002,7 +1002,7 @@
         </pc:sldMkLst>
       </pc:sldChg>
       <pc:sldChg chg="addSp delSp modSp add mod ord">
-        <pc:chgData name="Joseph Mata" userId="7bc4e0a3-43fe-410e-ab0b-dd6ac2ed59a7" providerId="ADAL" clId="{20AA238B-BA4D-59F0-BE88-0BD221C4FFE9}" dt="2026-03-18T04:13:29.528" v="2712" actId="20578"/>
+        <pc:chgData name="Joseph Mata" userId="7bc4e0a3-43fe-410e-ab0b-dd6ac2ed59a7" providerId="ADAL" clId="{20AA238B-BA4D-59F0-BE88-0BD221C4FFE9}" dt="2026-03-19T03:05:39.221" v="5193" actId="478"/>
         <pc:sldMkLst>
           <pc:docMk/>
           <pc:sldMk cId="98661325" sldId="2147483427"/>
@@ -1039,6 +1039,14 @@
             <ac:picMk id="8" creationId="{D2B18707-102C-CF10-6D0A-0B2E85ED086B}"/>
           </ac:picMkLst>
         </pc:picChg>
+        <pc:picChg chg="del">
+          <ac:chgData name="Joseph Mata" userId="7bc4e0a3-43fe-410e-ab0b-dd6ac2ed59a7" providerId="ADAL" clId="{20AA238B-BA4D-59F0-BE88-0BD221C4FFE9}" dt="2026-03-19T03:05:39.221" v="5193" actId="478"/>
+          <ac:picMkLst>
+            <pc:docMk/>
+            <pc:sldMk cId="98661325" sldId="2147483427"/>
+            <ac:picMk id="9" creationId="{BD2C7557-2F95-E7EA-0890-D4C5983AAA4F}"/>
+          </ac:picMkLst>
+        </pc:picChg>
         <pc:picChg chg="add del mod">
           <ac:chgData name="Joseph Mata" userId="7bc4e0a3-43fe-410e-ab0b-dd6ac2ed59a7" providerId="ADAL" clId="{20AA238B-BA4D-59F0-BE88-0BD221C4FFE9}" dt="2026-03-18T04:08:15.680" v="2696" actId="478"/>
           <ac:picMkLst>
@@ -1063,8 +1071,8 @@
             <ac:picMk id="15" creationId="{17A65D12-BD72-270E-F1A8-3895DE1B5FFB}"/>
           </ac:picMkLst>
         </pc:picChg>
-        <pc:picChg chg="add mod">
-          <ac:chgData name="Joseph Mata" userId="7bc4e0a3-43fe-410e-ab0b-dd6ac2ed59a7" providerId="ADAL" clId="{20AA238B-BA4D-59F0-BE88-0BD221C4FFE9}" dt="2026-03-18T04:10:38.257" v="2711" actId="1076"/>
+        <pc:picChg chg="add del mod">
+          <ac:chgData name="Joseph Mata" userId="7bc4e0a3-43fe-410e-ab0b-dd6ac2ed59a7" providerId="ADAL" clId="{20AA238B-BA4D-59F0-BE88-0BD221C4FFE9}" dt="2026-03-19T03:05:37.328" v="5192" actId="478"/>
           <ac:picMkLst>
             <pc:docMk/>
             <pc:sldMk cId="98661325" sldId="2147483427"/>
@@ -1942,18 +1950,6 @@
           </a:p>
           <a:p>
             <a:pPr rtl="0"/>
-            <a:r>
-              <a:rPr lang="en-US" sz="1200" b="0" i="0" u="none" strike="noStrike" kern="1200" dirty="0">
-                <a:solidFill>
-                  <a:schemeClr val="tx1"/>
-                </a:solidFill>
-                <a:effectLst/>
-                <a:latin typeface="+mn-lt"/>
-                <a:ea typeface="+mn-ea"/>
-                <a:cs typeface="+mn-cs"/>
-              </a:rPr>
-              <a:t>builds on the previous.</a:t>
-            </a:r>
             <a:endParaRPr lang="en-US" b="0" dirty="0">
               <a:effectLst/>
             </a:endParaRPr>
@@ -2312,69 +2308,6 @@
           </a:p>
           <a:p>
             <a:pPr rtl="0"/>
-            <a:r>
-              <a:rPr lang="en-US" sz="1200" b="0" i="0" u="none" strike="noStrike" kern="1200" dirty="0">
-                <a:solidFill>
-                  <a:schemeClr val="tx1"/>
-                </a:solidFill>
-                <a:effectLst/>
-                <a:latin typeface="+mn-lt"/>
-                <a:ea typeface="+mn-ea"/>
-                <a:cs typeface="+mn-cs"/>
-              </a:rPr>
-              <a:t>All the </a:t>
-            </a:r>
-            <a:r>
-              <a:rPr lang="en-US" sz="1200" b="0" i="0" u="none" strike="noStrike" kern="1200" dirty="0" err="1">
-                <a:solidFill>
-                  <a:schemeClr val="tx1"/>
-                </a:solidFill>
-                <a:effectLst/>
-                <a:latin typeface="+mn-lt"/>
-                <a:ea typeface="+mn-ea"/>
-                <a:cs typeface="+mn-cs"/>
-              </a:rPr>
-              <a:t>atifact</a:t>
-            </a:r>
-            <a:r>
-              <a:rPr lang="en-US" sz="1200" b="0" i="0" u="none" strike="noStrike" kern="1200" dirty="0">
-                <a:solidFill>
-                  <a:schemeClr val="tx1"/>
-                </a:solidFill>
-                <a:effectLst/>
-                <a:latin typeface="+mn-lt"/>
-                <a:ea typeface="+mn-ea"/>
-                <a:cs typeface="+mn-cs"/>
-              </a:rPr>
-              <a:t> </a:t>
-            </a:r>
-            <a:r>
-              <a:rPr lang="en-US" sz="1200" b="0" i="0" u="none" strike="noStrike" kern="1200" dirty="0" err="1">
-                <a:solidFill>
-                  <a:schemeClr val="tx1"/>
-                </a:solidFill>
-                <a:effectLst/>
-                <a:latin typeface="+mn-lt"/>
-                <a:ea typeface="+mn-ea"/>
-                <a:cs typeface="+mn-cs"/>
-              </a:rPr>
-              <a:t>oare</a:t>
-            </a:r>
-            <a:r>
-              <a:rPr lang="en-US" sz="1200" b="0" i="0" u="none" strike="noStrike" kern="1200" dirty="0">
-                <a:solidFill>
-                  <a:schemeClr val="tx1"/>
-                </a:solidFill>
-                <a:effectLst/>
-                <a:latin typeface="+mn-lt"/>
-                <a:ea typeface="+mn-ea"/>
-                <a:cs typeface="+mn-cs"/>
-              </a:rPr>
-              <a:t> summarized in the blueprint</a:t>
-            </a:r>
-          </a:p>
-          <a:p>
-            <a:pPr rtl="0"/>
             <a:endParaRPr lang="en-US" sz="1200" b="0" i="0" u="none" strike="noStrike" kern="1200" dirty="0">
               <a:solidFill>
                 <a:schemeClr val="tx1"/>
@@ -2397,7 +2330,7 @@
                 <a:ea typeface="+mn-ea"/>
                 <a:cs typeface="+mn-cs"/>
               </a:rPr>
-              <a:t>After making any edits well save our program and move on to configuring our exam agent Once edited and approved</a:t>
+              <a:t>After making any edits well save our program and move on to configuring our exam agent</a:t>
             </a:r>
             <a:br>
               <a:rPr lang="en-US" b="0" dirty="0">
@@ -2455,7 +2388,7 @@
             </a:pPr>
             <a:r>
               <a:rPr lang="en-US" dirty="0"/>
-              <a:t>You can adjust  how the AI scores open-ended responses, it's summary style as well, as create custom welcome and farewell messages to mirror company language.</a:t>
+              <a:t>You can adjust  how the agent scores open-ended responses, it's summary style as well, as create custom welcome and farewell messages to mirror company language.</a:t>
             </a:r>
           </a:p>
           <a:p>
@@ -2944,31 +2877,7 @@
                 <a:ea typeface="+mn-ea"/>
                 <a:cs typeface="+mn-cs"/>
               </a:rPr>
-              <a:t>we have Pass/fail distribution, score distribution</a:t>
-            </a:r>
-            <a:r>
-              <a:rPr lang="en-US" sz="1200" b="0" i="0" u="none" strike="noStrike" kern="1200">
-                <a:solidFill>
-                  <a:schemeClr val="tx1"/>
-                </a:solidFill>
-                <a:effectLst/>
-                <a:latin typeface="+mn-lt"/>
-                <a:ea typeface="+mn-ea"/>
-                <a:cs typeface="+mn-cs"/>
-              </a:rPr>
-              <a:t>, domain </a:t>
-            </a:r>
-            <a:r>
-              <a:rPr lang="en-US" sz="1200" b="0" i="0" u="none" strike="noStrike" kern="1200" dirty="0">
-                <a:solidFill>
-                  <a:schemeClr val="tx1"/>
-                </a:solidFill>
-                <a:effectLst/>
-                <a:latin typeface="+mn-lt"/>
-                <a:ea typeface="+mn-ea"/>
-                <a:cs typeface="+mn-cs"/>
-              </a:rPr>
-              <a:t>performance, and learner results </a:t>
+              <a:t>we have Pass/fail distribution, score distribution, domain performance, and learner results </a:t>
             </a:r>
           </a:p>
           <a:p>
@@ -3098,456 +3007,6 @@
           <a:bodyPr/>
           <a:lstStyle/>
           <a:p>
-            <a:pPr rtl="0"/>
-            <a:r>
-              <a:rPr lang="en-US" sz="1200" b="0" i="0" u="none" strike="noStrike" kern="1200" dirty="0">
-                <a:solidFill>
-                  <a:schemeClr val="tx1"/>
-                </a:solidFill>
-                <a:effectLst/>
-                <a:latin typeface="+mn-lt"/>
-                <a:ea typeface="+mn-ea"/>
-                <a:cs typeface="+mn-cs"/>
-              </a:rPr>
-              <a:t>Behold, </a:t>
-            </a:r>
-            <a:r>
-              <a:rPr lang="en-US" dirty="0" err="1"/>
-              <a:t>CertOps</a:t>
-            </a:r>
-            <a:r>
-              <a:rPr lang="en-US" dirty="0"/>
-              <a:t> is an AI-powered platform that builds certification programs and delivers adaptive exams. You provide the source content and the system generates a complete, structured program ready for learner assessment, analytics, and deployment.</a:t>
-            </a:r>
-          </a:p>
-          <a:p>
-            <a:pPr rtl="0"/>
-            <a:br>
-              <a:rPr lang="en-US" dirty="0"/>
-            </a:br>
-            <a:r>
-              <a:rPr lang="en-US" sz="1200" b="0" i="0" u="none" strike="noStrike" kern="1200" dirty="0">
-                <a:solidFill>
-                  <a:schemeClr val="tx1"/>
-                </a:solidFill>
-                <a:effectLst/>
-                <a:latin typeface="+mn-lt"/>
-                <a:ea typeface="+mn-ea"/>
-                <a:cs typeface="+mn-cs"/>
-              </a:rPr>
-              <a:t>builds on the previous.</a:t>
-            </a:r>
-            <a:endParaRPr lang="en-US" b="0" dirty="0">
-              <a:effectLst/>
-            </a:endParaRPr>
-          </a:p>
-          <a:p>
-            <a:br>
-              <a:rPr lang="en-US" b="0" dirty="0">
-                <a:effectLst/>
-              </a:rPr>
-            </a:br>
-            <a:endParaRPr lang="en-US" b="0" dirty="0">
-              <a:effectLst/>
-            </a:endParaRPr>
-          </a:p>
-          <a:p>
-            <a:pPr rtl="0"/>
-            <a:r>
-              <a:rPr lang="en-US" sz="1200" b="1" i="0" u="none" strike="noStrike" kern="1200" dirty="0">
-                <a:solidFill>
-                  <a:schemeClr val="tx1"/>
-                </a:solidFill>
-                <a:effectLst/>
-                <a:latin typeface="+mn-lt"/>
-                <a:ea typeface="+mn-ea"/>
-                <a:cs typeface="+mn-cs"/>
-              </a:rPr>
-              <a:t>The first is is build This is where a certification program is created.</a:t>
-            </a:r>
-            <a:endParaRPr lang="en-US" b="0" dirty="0">
-              <a:effectLst/>
-            </a:endParaRPr>
-          </a:p>
-          <a:p>
-            <a:pPr rtl="0"/>
-            <a:r>
-              <a:rPr lang="en-US" sz="1200" b="1" i="0" u="none" strike="noStrike" kern="1200" dirty="0">
-                <a:solidFill>
-                  <a:schemeClr val="tx1"/>
-                </a:solidFill>
-                <a:effectLst/>
-                <a:latin typeface="+mn-lt"/>
-                <a:ea typeface="+mn-ea"/>
-                <a:cs typeface="+mn-cs"/>
-              </a:rPr>
-              <a:t>Upload your external and internal content.</a:t>
-            </a:r>
-            <a:r>
-              <a:rPr lang="en-US" sz="1200" b="0" i="0" u="none" strike="noStrike" kern="1200" dirty="0">
-                <a:solidFill>
-                  <a:schemeClr val="tx1"/>
-                </a:solidFill>
-                <a:effectLst/>
-                <a:latin typeface="+mn-lt"/>
-                <a:ea typeface="+mn-ea"/>
-                <a:cs typeface="+mn-cs"/>
-              </a:rPr>
-              <a:t> Add a program name and a short description of who the certification is for and what it should cover. The description steers which parts of the uploaded content are prioritized during generation.</a:t>
-            </a:r>
-            <a:endParaRPr lang="en-US" b="0" dirty="0">
-              <a:effectLst/>
-            </a:endParaRPr>
-          </a:p>
-          <a:p>
-            <a:pPr rtl="0"/>
-            <a:r>
-              <a:rPr lang="en-US" sz="1200" b="0" i="0" u="none" strike="noStrike" kern="1200" dirty="0">
-                <a:solidFill>
-                  <a:schemeClr val="tx1"/>
-                </a:solidFill>
-                <a:effectLst/>
-                <a:latin typeface="+mn-lt"/>
-                <a:ea typeface="+mn-ea"/>
-                <a:cs typeface="+mn-cs"/>
-              </a:rPr>
-              <a:t>Using that </a:t>
-            </a:r>
-            <a:r>
-              <a:rPr lang="en-US" sz="1200" b="0" i="0" u="none" strike="noStrike" kern="1200" dirty="0" err="1">
-                <a:solidFill>
-                  <a:schemeClr val="tx1"/>
-                </a:solidFill>
-                <a:effectLst/>
-                <a:latin typeface="+mn-lt"/>
-                <a:ea typeface="+mn-ea"/>
-                <a:cs typeface="+mn-cs"/>
-              </a:rPr>
-              <a:t>informationCertOps</a:t>
-            </a:r>
-            <a:r>
-              <a:rPr lang="en-US" sz="1200" b="0" i="0" u="none" strike="noStrike" kern="1200" dirty="0">
-                <a:solidFill>
-                  <a:schemeClr val="tx1"/>
-                </a:solidFill>
-                <a:effectLst/>
-                <a:latin typeface="+mn-lt"/>
-                <a:ea typeface="+mn-ea"/>
-                <a:cs typeface="+mn-cs"/>
-              </a:rPr>
-              <a:t> generates six artifacts in order. </a:t>
-            </a:r>
-            <a:endParaRPr lang="en-US" b="0" dirty="0">
-              <a:effectLst/>
-            </a:endParaRPr>
-          </a:p>
-          <a:p>
-            <a:pPr rtl="0"/>
-            <a:r>
-              <a:rPr lang="en-US" sz="1200" b="1" i="0" u="none" strike="noStrike" kern="1200" dirty="0">
-                <a:solidFill>
-                  <a:schemeClr val="tx1"/>
-                </a:solidFill>
-                <a:effectLst/>
-                <a:latin typeface="+mn-lt"/>
-                <a:ea typeface="+mn-ea"/>
-                <a:cs typeface="+mn-cs"/>
-              </a:rPr>
-              <a:t>1. Competency Framework</a:t>
-            </a:r>
-            <a:endParaRPr lang="en-US" b="1" dirty="0">
-              <a:effectLst/>
-            </a:endParaRPr>
-          </a:p>
-          <a:p>
-            <a:pPr rtl="0"/>
-            <a:r>
-              <a:rPr lang="en-US" sz="1200" b="0" i="0" u="none" strike="noStrike" kern="1200" dirty="0">
-                <a:solidFill>
-                  <a:schemeClr val="tx1"/>
-                </a:solidFill>
-                <a:effectLst/>
-                <a:latin typeface="+mn-lt"/>
-                <a:ea typeface="+mn-ea"/>
-                <a:cs typeface="+mn-cs"/>
-              </a:rPr>
-              <a:t>defines the domains (topic areas) the certification covers, the specific skills within each domain, and what novice, competent, and expert performance looks like for each skill.</a:t>
-            </a:r>
-            <a:endParaRPr lang="en-US" b="0" dirty="0">
-              <a:effectLst/>
-            </a:endParaRPr>
-          </a:p>
-          <a:p>
-            <a:br>
-              <a:rPr lang="en-US" b="0" dirty="0">
-                <a:effectLst/>
-              </a:rPr>
-            </a:br>
-            <a:endParaRPr lang="en-US" b="0" dirty="0">
-              <a:effectLst/>
-            </a:endParaRPr>
-          </a:p>
-          <a:p>
-            <a:pPr rtl="0"/>
-            <a:r>
-              <a:rPr lang="en-US" sz="1200" b="1" i="0" u="none" strike="noStrike" kern="1200" dirty="0">
-                <a:solidFill>
-                  <a:schemeClr val="tx1"/>
-                </a:solidFill>
-                <a:effectLst/>
-                <a:latin typeface="+mn-lt"/>
-                <a:ea typeface="+mn-ea"/>
-                <a:cs typeface="+mn-cs"/>
-              </a:rPr>
-              <a:t>2. Learning Progression</a:t>
-            </a:r>
-            <a:endParaRPr lang="en-US" b="1" dirty="0">
-              <a:effectLst/>
-            </a:endParaRPr>
-          </a:p>
-          <a:p>
-            <a:pPr rtl="0"/>
-            <a:r>
-              <a:rPr lang="en-US" sz="1200" b="0" i="0" u="none" strike="noStrike" kern="1200" dirty="0">
-                <a:solidFill>
-                  <a:schemeClr val="tx1"/>
-                </a:solidFill>
-                <a:effectLst/>
-                <a:latin typeface="+mn-lt"/>
-                <a:ea typeface="+mn-ea"/>
-                <a:cs typeface="+mn-cs"/>
-              </a:rPr>
-              <a:t>that maps out how a learner should prepare for the certification. Each step includes a title, which domain it covers, suggested activities, estimated time, prerequisites, and success criteria.</a:t>
-            </a:r>
-            <a:endParaRPr lang="en-US" b="0" dirty="0">
-              <a:effectLst/>
-            </a:endParaRPr>
-          </a:p>
-          <a:p>
-            <a:br>
-              <a:rPr lang="en-US" b="0" dirty="0">
-                <a:effectLst/>
-              </a:rPr>
-            </a:br>
-            <a:endParaRPr lang="en-US" b="0" dirty="0">
-              <a:effectLst/>
-            </a:endParaRPr>
-          </a:p>
-          <a:p>
-            <a:pPr rtl="0"/>
-            <a:r>
-              <a:rPr lang="en-US" sz="1200" b="1" i="0" u="none" strike="noStrike" kern="1200" dirty="0">
-                <a:solidFill>
-                  <a:schemeClr val="tx1"/>
-                </a:solidFill>
-                <a:effectLst/>
-                <a:latin typeface="+mn-lt"/>
-                <a:ea typeface="+mn-ea"/>
-                <a:cs typeface="+mn-cs"/>
-              </a:rPr>
-              <a:t>3. Performance Tasks</a:t>
-            </a:r>
-            <a:endParaRPr lang="en-US" b="1" dirty="0">
-              <a:effectLst/>
-            </a:endParaRPr>
-          </a:p>
-          <a:p>
-            <a:pPr rtl="0"/>
-            <a:r>
-              <a:rPr lang="en-US" sz="1200" b="0" i="0" u="none" strike="noStrike" kern="1200" dirty="0">
-                <a:solidFill>
-                  <a:schemeClr val="tx1"/>
-                </a:solidFill>
-                <a:effectLst/>
-                <a:latin typeface="+mn-lt"/>
-                <a:ea typeface="+mn-ea"/>
-                <a:cs typeface="+mn-cs"/>
-              </a:rPr>
-              <a:t>Hands-on, project-style tasks that test whether a learner can apply their knowledge in realistic scenarios. Each assessment includes a scenario description, step-by-step instructions, expected deliverables, and an evaluator guide.</a:t>
-            </a:r>
-            <a:endParaRPr lang="en-US" b="0" dirty="0">
-              <a:effectLst/>
-            </a:endParaRPr>
-          </a:p>
-          <a:p>
-            <a:br>
-              <a:rPr lang="en-US" b="0" dirty="0">
-                <a:effectLst/>
-              </a:rPr>
-            </a:br>
-            <a:endParaRPr lang="en-US" b="0" dirty="0">
-              <a:effectLst/>
-            </a:endParaRPr>
-          </a:p>
-          <a:p>
-            <a:pPr rtl="0"/>
-            <a:r>
-              <a:rPr lang="en-US" sz="1200" b="1" i="0" u="none" strike="noStrike" kern="1200" dirty="0">
-                <a:solidFill>
-                  <a:schemeClr val="tx1"/>
-                </a:solidFill>
-                <a:effectLst/>
-                <a:latin typeface="+mn-lt"/>
-                <a:ea typeface="+mn-ea"/>
-                <a:cs typeface="+mn-cs"/>
-              </a:rPr>
-              <a:t>4. Rubrics</a:t>
-            </a:r>
-            <a:endParaRPr lang="en-US" b="1" dirty="0">
-              <a:effectLst/>
-            </a:endParaRPr>
-          </a:p>
-          <a:p>
-            <a:pPr rtl="0"/>
-            <a:r>
-              <a:rPr lang="en-US" sz="1200" b="1" i="0" u="none" strike="noStrike" kern="1200" dirty="0">
-                <a:solidFill>
-                  <a:schemeClr val="tx1"/>
-                </a:solidFill>
-                <a:effectLst/>
-                <a:latin typeface="+mn-lt"/>
-                <a:ea typeface="+mn-ea"/>
-                <a:cs typeface="+mn-cs"/>
-              </a:rPr>
-              <a:t>What it is:</a:t>
-            </a:r>
-            <a:r>
-              <a:rPr lang="en-US" sz="1200" b="0" i="0" u="none" strike="noStrike" kern="1200" dirty="0">
-                <a:solidFill>
-                  <a:schemeClr val="tx1"/>
-                </a:solidFill>
-                <a:effectLst/>
-                <a:latin typeface="+mn-lt"/>
-                <a:ea typeface="+mn-ea"/>
-                <a:cs typeface="+mn-cs"/>
-              </a:rPr>
-              <a:t> Scoring guides for the </a:t>
-            </a:r>
-            <a:r>
-              <a:rPr lang="en-US" sz="1200" b="0" i="0" u="none" strike="noStrike" kern="1200" dirty="0" err="1">
-                <a:solidFill>
-                  <a:schemeClr val="tx1"/>
-                </a:solidFill>
-                <a:effectLst/>
-                <a:latin typeface="+mn-lt"/>
-                <a:ea typeface="+mn-ea"/>
-                <a:cs typeface="+mn-cs"/>
-              </a:rPr>
-              <a:t>taks</a:t>
-            </a:r>
-            <a:r>
-              <a:rPr lang="en-US" sz="1200" b="0" i="0" u="none" strike="noStrike" kern="1200" dirty="0">
-                <a:solidFill>
-                  <a:schemeClr val="tx1"/>
-                </a:solidFill>
-                <a:effectLst/>
-                <a:latin typeface="+mn-lt"/>
-                <a:ea typeface="+mn-ea"/>
-                <a:cs typeface="+mn-cs"/>
-              </a:rPr>
-              <a:t>. Each rubric lists weighted criteria and describes what novice, competent, and expert work looks like for each criterion.</a:t>
-            </a:r>
-            <a:endParaRPr lang="en-US" b="0" dirty="0">
-              <a:effectLst/>
-            </a:endParaRPr>
-          </a:p>
-          <a:p>
-            <a:pPr rtl="0"/>
-            <a:r>
-              <a:rPr lang="en-US" sz="1200" b="1" i="0" u="none" strike="noStrike" kern="1200" dirty="0">
-                <a:solidFill>
-                  <a:schemeClr val="tx1"/>
-                </a:solidFill>
-                <a:effectLst/>
-                <a:latin typeface="+mn-lt"/>
-                <a:ea typeface="+mn-ea"/>
-                <a:cs typeface="+mn-cs"/>
-              </a:rPr>
-              <a:t>Why it matters:</a:t>
-            </a:r>
-            <a:r>
-              <a:rPr lang="en-US" sz="1200" b="0" i="0" u="none" strike="noStrike" kern="1200" dirty="0">
-                <a:solidFill>
-                  <a:schemeClr val="tx1"/>
-                </a:solidFill>
-                <a:effectLst/>
-                <a:latin typeface="+mn-lt"/>
-                <a:ea typeface="+mn-ea"/>
-                <a:cs typeface="+mn-cs"/>
-              </a:rPr>
-              <a:t> Rubrics ensure consistent, fair grading across evaluators. They are also used by the adaptive exam's AI when scoring open-ended answers, so the same quality standards apply in both human and automated evaluation.</a:t>
-            </a:r>
-            <a:endParaRPr lang="en-US" b="0" dirty="0">
-              <a:effectLst/>
-            </a:endParaRPr>
-          </a:p>
-          <a:p>
-            <a:pPr rtl="0"/>
-            <a:r>
-              <a:rPr lang="en-US" sz="1200" b="1" i="0" u="none" strike="noStrike" kern="1200" dirty="0">
-                <a:solidFill>
-                  <a:schemeClr val="tx1"/>
-                </a:solidFill>
-                <a:effectLst/>
-                <a:latin typeface="+mn-lt"/>
-                <a:ea typeface="+mn-ea"/>
-                <a:cs typeface="+mn-cs"/>
-              </a:rPr>
-              <a:t>5. Item Bank</a:t>
-            </a:r>
-            <a:endParaRPr lang="en-US" b="1" dirty="0">
-              <a:effectLst/>
-            </a:endParaRPr>
-          </a:p>
-          <a:p>
-            <a:pPr rtl="0"/>
-            <a:r>
-              <a:rPr lang="en-US" sz="1200" b="1" i="0" u="none" strike="noStrike" kern="1200" dirty="0">
-                <a:solidFill>
-                  <a:schemeClr val="tx1"/>
-                </a:solidFill>
-                <a:effectLst/>
-                <a:latin typeface="+mn-lt"/>
-                <a:ea typeface="+mn-ea"/>
-                <a:cs typeface="+mn-cs"/>
-              </a:rPr>
-              <a:t>What it is:</a:t>
-            </a:r>
-            <a:r>
-              <a:rPr lang="en-US" sz="1200" b="0" i="0" u="none" strike="noStrike" kern="1200" dirty="0">
-                <a:solidFill>
-                  <a:schemeClr val="tx1"/>
-                </a:solidFill>
-                <a:effectLst/>
-                <a:latin typeface="+mn-lt"/>
-                <a:ea typeface="+mn-ea"/>
-                <a:cs typeface="+mn-cs"/>
-              </a:rPr>
-              <a:t> The pool of exam questions that the automated exam draws from. Contains both multiple-choice and open-ended questions. Each item includes the correct answer, a model answer, scoring notes, and which domain/skill it maps to.</a:t>
-            </a:r>
-            <a:endParaRPr lang="en-US" b="0" dirty="0">
-              <a:effectLst/>
-            </a:endParaRPr>
-          </a:p>
-          <a:p>
-            <a:pPr rtl="0"/>
-            <a:r>
-              <a:rPr lang="en-US" sz="1200" b="0" i="0" u="none" strike="noStrike" kern="1200" dirty="0">
-                <a:solidFill>
-                  <a:schemeClr val="tx1"/>
-                </a:solidFill>
-                <a:effectLst/>
-                <a:latin typeface="+mn-lt"/>
-                <a:ea typeface="+mn-ea"/>
-                <a:cs typeface="+mn-cs"/>
-              </a:rPr>
-              <a:t>Individual items can be deleted to curate the pool before saving. If the item bank is larger than the configured maximum exam items, the exam uses stratified random sampling to select a subset — ensuring all domains are represented while varying which specific questions appear each session.</a:t>
-            </a:r>
-            <a:endParaRPr lang="en-US" b="0" dirty="0">
-              <a:effectLst/>
-            </a:endParaRPr>
-          </a:p>
-          <a:p>
             <a:br>
               <a:rPr lang="en-US" b="0" dirty="0">
                 <a:effectLst/>
@@ -3587,501 +3046,7 @@
                 <a:ea typeface="+mn-ea"/>
                 <a:cs typeface="+mn-cs"/>
               </a:rPr>
-              <a:t>This is the learner-facing experience — the adaptive exam.</a:t>
-            </a:r>
-            <a:endParaRPr lang="en-US" b="0" dirty="0">
-              <a:effectLst/>
-            </a:endParaRPr>
-          </a:p>
-          <a:p>
-            <a:pPr rtl="0" fontAlgn="base"/>
-            <a:r>
-              <a:rPr lang="en-US" sz="1200" b="0" i="0" u="none" strike="noStrike" kern="1200" dirty="0">
-                <a:solidFill>
-                  <a:schemeClr val="tx1"/>
-                </a:solidFill>
-                <a:effectLst/>
-                <a:latin typeface="+mn-lt"/>
-                <a:ea typeface="+mn-ea"/>
-                <a:cs typeface="+mn-cs"/>
-              </a:rPr>
-              <a:t>The learner selects a saved certification program and enters their name.</a:t>
-            </a:r>
-          </a:p>
-          <a:p>
-            <a:pPr rtl="0" fontAlgn="base"/>
-            <a:r>
-              <a:rPr lang="en-US" sz="1200" b="0" i="0" u="none" strike="noStrike" kern="1200" dirty="0">
-                <a:solidFill>
-                  <a:schemeClr val="tx1"/>
-                </a:solidFill>
-                <a:effectLst/>
-                <a:latin typeface="+mn-lt"/>
-                <a:ea typeface="+mn-ea"/>
-                <a:cs typeface="+mn-cs"/>
-              </a:rPr>
-              <a:t>The exam begins in a conversational chat interface. Questions appear one at a time.</a:t>
-            </a:r>
-          </a:p>
-          <a:p>
-            <a:pPr rtl="0" fontAlgn="base"/>
-            <a:r>
-              <a:rPr lang="en-US" sz="1200" b="0" i="0" u="none" strike="noStrike" kern="1200" dirty="0">
-                <a:solidFill>
-                  <a:schemeClr val="tx1"/>
-                </a:solidFill>
-                <a:effectLst/>
-                <a:latin typeface="+mn-lt"/>
-                <a:ea typeface="+mn-ea"/>
-                <a:cs typeface="+mn-cs"/>
-              </a:rPr>
-              <a:t>The system evaluates each answer in real time and selects the next question based on the learner's performance so far.</a:t>
-            </a:r>
-          </a:p>
-          <a:p>
-            <a:pPr rtl="0" fontAlgn="base"/>
-            <a:r>
-              <a:rPr lang="en-US" sz="1200" b="0" i="0" u="none" strike="noStrike" kern="1200" dirty="0">
-                <a:solidFill>
-                  <a:schemeClr val="tx1"/>
-                </a:solidFill>
-                <a:effectLst/>
-                <a:latin typeface="+mn-lt"/>
-                <a:ea typeface="+mn-ea"/>
-                <a:cs typeface="+mn-cs"/>
-              </a:rPr>
-              <a:t>When the exam ends, the learner sees their results: pass/fail, scores by domain, a narrative summary of strengths and gaps, and recommended next steps.</a:t>
-            </a:r>
-          </a:p>
-          <a:p>
-            <a:pPr rtl="0"/>
-            <a:r>
-              <a:rPr lang="en-US" sz="1200" b="1" i="0" u="none" strike="noStrike" kern="1200" dirty="0">
-                <a:solidFill>
-                  <a:schemeClr val="tx1"/>
-                </a:solidFill>
-                <a:effectLst/>
-                <a:latin typeface="+mn-lt"/>
-                <a:ea typeface="+mn-ea"/>
-                <a:cs typeface="+mn-cs"/>
-              </a:rPr>
-              <a:t>Deploy</a:t>
-            </a:r>
-            <a:endParaRPr lang="en-US" b="1" dirty="0">
-              <a:effectLst/>
-            </a:endParaRPr>
-          </a:p>
-          <a:p>
-            <a:pPr rtl="0"/>
-            <a:r>
-              <a:rPr lang="en-US" sz="1200" b="0" i="0" u="none" strike="noStrike" kern="1200" dirty="0">
-                <a:solidFill>
-                  <a:schemeClr val="tx1"/>
-                </a:solidFill>
-                <a:effectLst/>
-                <a:latin typeface="+mn-lt"/>
-                <a:ea typeface="+mn-ea"/>
-                <a:cs typeface="+mn-cs"/>
-              </a:rPr>
-              <a:t>Saved programs are managed from the Deploy page.</a:t>
-            </a:r>
-            <a:endParaRPr lang="en-US" b="0" dirty="0">
-              <a:effectLst/>
-            </a:endParaRPr>
-          </a:p>
-          <a:p>
-            <a:pPr rtl="0" fontAlgn="base"/>
-            <a:r>
-              <a:rPr lang="en-US" sz="1200" b="1" i="0" u="none" strike="noStrike" kern="1200" dirty="0">
-                <a:solidFill>
-                  <a:schemeClr val="tx1"/>
-                </a:solidFill>
-                <a:effectLst/>
-                <a:latin typeface="+mn-lt"/>
-                <a:ea typeface="+mn-ea"/>
-                <a:cs typeface="+mn-cs"/>
-              </a:rPr>
-              <a:t>Browse saved </a:t>
-            </a:r>
-            <a:r>
-              <a:rPr lang="en-US" sz="1200" b="1" i="0" u="none" strike="noStrike" kern="1200" dirty="0" err="1">
-                <a:solidFill>
-                  <a:schemeClr val="tx1"/>
-                </a:solidFill>
-                <a:effectLst/>
-                <a:latin typeface="+mn-lt"/>
-                <a:ea typeface="+mn-ea"/>
-                <a:cs typeface="+mn-cs"/>
-              </a:rPr>
-              <a:t>progra</a:t>
-            </a:r>
-            <a:endParaRPr lang="en-US" sz="1200" b="0" i="0" u="none" strike="noStrike" kern="1200" dirty="0">
-              <a:solidFill>
-                <a:schemeClr val="tx1"/>
-              </a:solidFill>
-              <a:effectLst/>
-              <a:latin typeface="+mn-lt"/>
-              <a:ea typeface="+mn-ea"/>
-              <a:cs typeface="+mn-cs"/>
-            </a:endParaRPr>
-          </a:p>
-          <a:p>
-            <a:pPr rtl="0" fontAlgn="base"/>
-            <a:r>
-              <a:rPr lang="en-US" sz="1200" b="1" i="0" u="none" strike="noStrike" kern="1200" dirty="0">
-                <a:solidFill>
-                  <a:schemeClr val="tx1"/>
-                </a:solidFill>
-                <a:effectLst/>
-                <a:latin typeface="+mn-lt"/>
-                <a:ea typeface="+mn-ea"/>
-                <a:cs typeface="+mn-cs"/>
-              </a:rPr>
-              <a:t>Download reports</a:t>
-            </a:r>
-            <a:r>
-              <a:rPr lang="en-US" sz="1200" b="0" i="0" u="none" strike="noStrike" kern="1200" dirty="0">
-                <a:solidFill>
-                  <a:schemeClr val="tx1"/>
-                </a:solidFill>
-                <a:effectLst/>
-                <a:latin typeface="+mn-lt"/>
-                <a:ea typeface="+mn-ea"/>
-                <a:cs typeface="+mn-cs"/>
-              </a:rPr>
-              <a:t> the house all the content </a:t>
-            </a:r>
-            <a:r>
-              <a:rPr lang="en-US" sz="1200" b="0" i="0" u="none" strike="noStrike" kern="1200" dirty="0" err="1">
-                <a:solidFill>
-                  <a:schemeClr val="tx1"/>
-                </a:solidFill>
-                <a:effectLst/>
-                <a:latin typeface="+mn-lt"/>
-                <a:ea typeface="+mn-ea"/>
-                <a:cs typeface="+mn-cs"/>
-              </a:rPr>
-              <a:t>createsredaytos</a:t>
-            </a:r>
-            <a:r>
-              <a:rPr lang="en-US" sz="1200" b="0" i="0" u="none" strike="noStrike" kern="1200" dirty="0">
-                <a:solidFill>
-                  <a:schemeClr val="tx1"/>
-                </a:solidFill>
-                <a:effectLst/>
-                <a:latin typeface="+mn-lt"/>
-                <a:ea typeface="+mn-ea"/>
-                <a:cs typeface="+mn-cs"/>
-              </a:rPr>
-              <a:t> hare with shared with stakeholders.</a:t>
-            </a:r>
-          </a:p>
-          <a:p>
-            <a:pPr rtl="0" fontAlgn="base"/>
-            <a:r>
-              <a:rPr lang="en-US" sz="1200" b="1" i="0" u="none" strike="noStrike" kern="1200" dirty="0">
-                <a:solidFill>
-                  <a:schemeClr val="tx1"/>
-                </a:solidFill>
-                <a:effectLst/>
-                <a:latin typeface="+mn-lt"/>
-                <a:ea typeface="+mn-ea"/>
-                <a:cs typeface="+mn-cs"/>
-              </a:rPr>
-              <a:t>Share exams</a:t>
-            </a:r>
-            <a:r>
-              <a:rPr lang="en-US" sz="1200" b="0" i="0" u="none" strike="noStrike" kern="1200" dirty="0">
-                <a:solidFill>
-                  <a:schemeClr val="tx1"/>
-                </a:solidFill>
-                <a:effectLst/>
-                <a:latin typeface="+mn-lt"/>
-                <a:ea typeface="+mn-ea"/>
-                <a:cs typeface="+mn-cs"/>
-              </a:rPr>
-              <a:t> — Copy a direct link to the exam or grab an embeddable </a:t>
-            </a:r>
-            <a:r>
-              <a:rPr lang="en-US" sz="1200" b="0" i="0" u="none" strike="noStrike" kern="1200" dirty="0" err="1">
-                <a:solidFill>
-                  <a:schemeClr val="tx1"/>
-                </a:solidFill>
-                <a:effectLst/>
-                <a:latin typeface="+mn-lt"/>
-                <a:ea typeface="+mn-ea"/>
-                <a:cs typeface="+mn-cs"/>
-              </a:rPr>
-              <a:t>iframe</a:t>
-            </a:r>
-            <a:r>
-              <a:rPr lang="en-US" sz="1200" b="0" i="0" u="none" strike="noStrike" kern="1200" dirty="0">
-                <a:solidFill>
-                  <a:schemeClr val="tx1"/>
-                </a:solidFill>
-                <a:effectLst/>
-                <a:latin typeface="+mn-lt"/>
-                <a:ea typeface="+mn-ea"/>
-                <a:cs typeface="+mn-cs"/>
-              </a:rPr>
-              <a:t> snippet for LMS integration.</a:t>
-            </a:r>
-          </a:p>
-          <a:p>
-            <a:pPr rtl="0" fontAlgn="base"/>
-            <a:r>
-              <a:rPr lang="en-US" sz="1200" b="1" i="0" u="none" strike="noStrike" kern="1200" dirty="0">
-                <a:solidFill>
-                  <a:schemeClr val="tx1"/>
-                </a:solidFill>
-                <a:effectLst/>
-                <a:latin typeface="+mn-lt"/>
-                <a:ea typeface="+mn-ea"/>
-                <a:cs typeface="+mn-cs"/>
-              </a:rPr>
-              <a:t>Add documents</a:t>
-            </a:r>
-            <a:r>
-              <a:rPr lang="en-US" sz="1200" b="0" i="0" u="none" strike="noStrike" kern="1200" dirty="0">
-                <a:solidFill>
-                  <a:schemeClr val="tx1"/>
-                </a:solidFill>
-                <a:effectLst/>
-                <a:latin typeface="+mn-lt"/>
-                <a:ea typeface="+mn-ea"/>
-                <a:cs typeface="+mn-cs"/>
-              </a:rPr>
-              <a:t> — Upload additional rich a program's knowledge base for when your ready to rebuild New documents are embedded into the existing vector store, so the program can be rebuilt with a richer corpus.</a:t>
-            </a:r>
-          </a:p>
-          <a:p>
-            <a:pPr rtl="0"/>
-            <a:r>
-              <a:rPr lang="en-US" sz="1200" b="1" i="0" u="none" strike="noStrike" kern="1200" dirty="0">
-                <a:solidFill>
-                  <a:schemeClr val="tx1"/>
-                </a:solidFill>
-                <a:effectLst/>
-                <a:latin typeface="+mn-lt"/>
-                <a:ea typeface="+mn-ea"/>
-                <a:cs typeface="+mn-cs"/>
-              </a:rPr>
-              <a:t>Analyze</a:t>
-            </a:r>
-            <a:endParaRPr lang="en-US" b="1" dirty="0">
-              <a:effectLst/>
-            </a:endParaRPr>
-          </a:p>
-          <a:p>
-            <a:pPr rtl="0"/>
-            <a:r>
-              <a:rPr lang="en-US" sz="1200" b="0" i="0" u="none" strike="noStrike" kern="1200" dirty="0">
-                <a:solidFill>
-                  <a:schemeClr val="tx1"/>
-                </a:solidFill>
-                <a:effectLst/>
-                <a:latin typeface="+mn-lt"/>
-                <a:ea typeface="+mn-ea"/>
-                <a:cs typeface="+mn-cs"/>
-              </a:rPr>
-              <a:t>The Analyze page provides aggregate analytics across all learner attempts.</a:t>
-            </a:r>
-            <a:endParaRPr lang="en-US" b="0" dirty="0">
-              <a:effectLst/>
-            </a:endParaRPr>
-          </a:p>
-          <a:p>
-            <a:pPr rtl="0" fontAlgn="base"/>
-            <a:r>
-              <a:rPr lang="en-US" sz="1200" b="1" i="0" u="none" strike="noStrike" kern="1200" dirty="0">
-                <a:solidFill>
-                  <a:schemeClr val="tx1"/>
-                </a:solidFill>
-                <a:effectLst/>
-                <a:latin typeface="+mn-lt"/>
-                <a:ea typeface="+mn-ea"/>
-                <a:cs typeface="+mn-cs"/>
-              </a:rPr>
-              <a:t>Summary view</a:t>
-            </a:r>
-            <a:r>
-              <a:rPr lang="en-US" sz="1200" b="0" i="0" u="none" strike="noStrike" kern="1200" dirty="0">
-                <a:solidFill>
-                  <a:schemeClr val="tx1"/>
-                </a:solidFill>
-                <a:effectLst/>
-                <a:latin typeface="+mn-lt"/>
-                <a:ea typeface="+mn-ea"/>
-                <a:cs typeface="+mn-cs"/>
-              </a:rPr>
-              <a:t> — Cards for each program showing total attempts, pass rate, and average score.</a:t>
-            </a:r>
-          </a:p>
-          <a:p>
-            <a:pPr rtl="0" fontAlgn="base"/>
-            <a:r>
-              <a:rPr lang="en-US" sz="1200" b="1" i="0" u="none" strike="noStrike" kern="1200" dirty="0">
-                <a:solidFill>
-                  <a:schemeClr val="tx1"/>
-                </a:solidFill>
-                <a:effectLst/>
-                <a:latin typeface="+mn-lt"/>
-                <a:ea typeface="+mn-ea"/>
-                <a:cs typeface="+mn-cs"/>
-              </a:rPr>
-              <a:t>Program drill-down</a:t>
-            </a:r>
-            <a:r>
-              <a:rPr lang="en-US" sz="1200" b="0" i="0" u="none" strike="noStrike" kern="1200" dirty="0">
-                <a:solidFill>
-                  <a:schemeClr val="tx1"/>
-                </a:solidFill>
-                <a:effectLst/>
-                <a:latin typeface="+mn-lt"/>
-                <a:ea typeface="+mn-ea"/>
-                <a:cs typeface="+mn-cs"/>
-              </a:rPr>
-              <a:t> — Click a program to see detailed analytics:</a:t>
-            </a:r>
-          </a:p>
-          <a:p>
-            <a:pPr lvl="1" rtl="0" fontAlgn="base"/>
-            <a:r>
-              <a:rPr lang="en-US" sz="1200" b="0" i="0" u="none" strike="noStrike" kern="1200" dirty="0">
-                <a:solidFill>
-                  <a:schemeClr val="tx1"/>
-                </a:solidFill>
-                <a:effectLst/>
-                <a:latin typeface="+mn-lt"/>
-                <a:ea typeface="+mn-ea"/>
-                <a:cs typeface="+mn-cs"/>
-              </a:rPr>
-              <a:t>Pass/fail distribution (donut chart with pass rate percentage)</a:t>
-            </a:r>
-          </a:p>
-          <a:p>
-            <a:pPr lvl="1" rtl="0" fontAlgn="base"/>
-            <a:r>
-              <a:rPr lang="en-US" sz="1200" b="0" i="0" u="none" strike="noStrike" kern="1200" dirty="0">
-                <a:solidFill>
-                  <a:schemeClr val="tx1"/>
-                </a:solidFill>
-                <a:effectLst/>
-                <a:latin typeface="+mn-lt"/>
-                <a:ea typeface="+mn-ea"/>
-                <a:cs typeface="+mn-cs"/>
-              </a:rPr>
-              <a:t>Score distribution (histogram of learner scores)</a:t>
-            </a:r>
-          </a:p>
-          <a:p>
-            <a:pPr lvl="1" rtl="0" fontAlgn="base"/>
-            <a:r>
-              <a:rPr lang="en-US" sz="1200" b="0" i="0" u="none" strike="noStrike" kern="1200" dirty="0">
-                <a:solidFill>
-                  <a:schemeClr val="tx1"/>
-                </a:solidFill>
-                <a:effectLst/>
-                <a:latin typeface="+mn-lt"/>
-                <a:ea typeface="+mn-ea"/>
-                <a:cs typeface="+mn-cs"/>
-              </a:rPr>
-              <a:t>Domain performance (per-domain average scores)</a:t>
-            </a:r>
-          </a:p>
-          <a:p>
-            <a:pPr lvl="1" rtl="0" fontAlgn="base"/>
-            <a:r>
-              <a:rPr lang="en-US" sz="1200" b="0" i="0" u="none" strike="noStrike" kern="1200" dirty="0">
-                <a:solidFill>
-                  <a:schemeClr val="tx1"/>
-                </a:solidFill>
-                <a:effectLst/>
-                <a:latin typeface="+mn-lt"/>
-                <a:ea typeface="+mn-ea"/>
-                <a:cs typeface="+mn-cs"/>
-              </a:rPr>
-              <a:t>Proficiency distribution (novice/competent/expert counts per domain)</a:t>
-            </a:r>
-          </a:p>
-          <a:p>
-            <a:pPr lvl="1" rtl="0" fontAlgn="base"/>
-            <a:r>
-              <a:rPr lang="en-US" sz="1200" b="0" i="0" u="none" strike="noStrike" kern="1200" dirty="0">
-                <a:solidFill>
-                  <a:schemeClr val="tx1"/>
-                </a:solidFill>
-                <a:effectLst/>
-                <a:latin typeface="+mn-lt"/>
-                <a:ea typeface="+mn-ea"/>
-                <a:cs typeface="+mn-cs"/>
-              </a:rPr>
-              <a:t>Score trend over time</a:t>
-            </a:r>
-          </a:p>
-          <a:p>
-            <a:pPr lvl="1" rtl="0" fontAlgn="base"/>
-            <a:r>
-              <a:rPr lang="en-US" sz="1200" b="0" i="0" u="none" strike="noStrike" kern="1200" dirty="0">
-                <a:solidFill>
-                  <a:schemeClr val="tx1"/>
-                </a:solidFill>
-                <a:effectLst/>
-                <a:latin typeface="+mn-lt"/>
-                <a:ea typeface="+mn-ea"/>
-                <a:cs typeface="+mn-cs"/>
-              </a:rPr>
-              <a:t>Learner results table (alphabetically sorted, with per-learner domain breakdown)</a:t>
-            </a:r>
-          </a:p>
-          <a:p>
-            <a:r>
-              <a:rPr lang="en-US" sz="1200" b="1" i="0" u="none" strike="noStrike" kern="1200" dirty="0">
-                <a:solidFill>
-                  <a:schemeClr val="tx1"/>
-                </a:solidFill>
-                <a:effectLst/>
-                <a:latin typeface="+mn-lt"/>
-                <a:ea typeface="+mn-ea"/>
-                <a:cs typeface="+mn-cs"/>
-              </a:rPr>
-              <a:t>All </a:t>
-            </a:r>
-            <a:r>
-              <a:rPr lang="en-US" sz="1200" b="1" i="0" u="none" strike="noStrike" kern="1200" dirty="0" err="1">
-                <a:solidFill>
-                  <a:schemeClr val="tx1"/>
-                </a:solidFill>
-                <a:effectLst/>
-                <a:latin typeface="+mn-lt"/>
-                <a:ea typeface="+mn-ea"/>
-                <a:cs typeface="+mn-cs"/>
-              </a:rPr>
-              <a:t>resultscan</a:t>
-            </a:r>
-            <a:r>
-              <a:rPr lang="en-US" sz="1200" b="1" i="0" u="none" strike="noStrike" kern="1200" dirty="0">
-                <a:solidFill>
-                  <a:schemeClr val="tx1"/>
-                </a:solidFill>
-                <a:effectLst/>
-                <a:latin typeface="+mn-lt"/>
-                <a:ea typeface="+mn-ea"/>
-                <a:cs typeface="+mn-cs"/>
-              </a:rPr>
-              <a:t> e exported for </a:t>
-            </a:r>
-            <a:r>
-              <a:rPr lang="en-US" sz="1200" b="0" i="0" u="none" strike="noStrike" kern="1200" dirty="0">
-                <a:solidFill>
-                  <a:schemeClr val="tx1"/>
-                </a:solidFill>
-                <a:effectLst/>
-                <a:latin typeface="+mn-lt"/>
-                <a:ea typeface="+mn-ea"/>
-                <a:cs typeface="+mn-cs"/>
-              </a:rPr>
-              <a:t>offline analysis or reporting.</a:t>
+              <a:t>This is the</a:t>
             </a:r>
             <a:endParaRPr lang="en-US" dirty="0"/>
           </a:p>
@@ -18258,70 +17223,6 @@
           <a:chExt cx="0" cy="0"/>
         </a:xfrm>
       </p:grpSpPr>
-      <p:pic>
-        <p:nvPicPr>
-          <p:cNvPr id="9" name="Image 0" descr="/tmp/certops-slides/screenshots/homepage.png">
-            <a:extLst>
-              <a:ext uri="{FF2B5EF4-FFF2-40B4-BE49-F238E27FC236}">
-                <a16:creationId xmlns:a16="http://schemas.microsoft.com/office/drawing/2014/main" id="{BD2C7557-2F95-E7EA-0890-D4C5983AAA4F}"/>
-              </a:ext>
-            </a:extLst>
-          </p:cNvPr>
-          <p:cNvPicPr>
-            <a:picLocks noChangeAspect="1"/>
-          </p:cNvPicPr>
-          <p:nvPr/>
-        </p:nvPicPr>
-        <p:blipFill>
-          <a:blip r:embed="rId3"/>
-          <a:srcRect l="17298" t="29706" r="17441" b="42067"/>
-          <a:stretch>
-            <a:fillRect/>
-          </a:stretch>
-        </p:blipFill>
-        <p:spPr>
-          <a:xfrm>
-            <a:off x="2065662" y="3402835"/>
-            <a:ext cx="5012675" cy="1355076"/>
-          </a:xfrm>
-          <a:prstGeom prst="rect">
-            <a:avLst/>
-          </a:prstGeom>
-          <a:effectLst>
-            <a:softEdge rad="63500"/>
-          </a:effectLst>
-        </p:spPr>
-      </p:pic>
-      <p:pic>
-        <p:nvPicPr>
-          <p:cNvPr id="17" name="Picture 16">
-            <a:extLst>
-              <a:ext uri="{FF2B5EF4-FFF2-40B4-BE49-F238E27FC236}">
-                <a16:creationId xmlns:a16="http://schemas.microsoft.com/office/drawing/2014/main" id="{7F83CCD4-A2B5-F67A-990E-589DC7898A21}"/>
-              </a:ext>
-            </a:extLst>
-          </p:cNvPr>
-          <p:cNvPicPr>
-            <a:picLocks noChangeAspect="1"/>
-          </p:cNvPicPr>
-          <p:nvPr/>
-        </p:nvPicPr>
-        <p:blipFill>
-          <a:blip r:embed="rId4"/>
-          <a:stretch>
-            <a:fillRect/>
-          </a:stretch>
-        </p:blipFill>
-        <p:spPr>
-          <a:xfrm>
-            <a:off x="-1841939" y="-326562"/>
-            <a:ext cx="12827876" cy="5212888"/>
-          </a:xfrm>
-          <a:prstGeom prst="rect">
-            <a:avLst/>
-          </a:prstGeom>
-        </p:spPr>
-      </p:pic>
     </p:spTree>
     <p:extLst>
       <p:ext uri="{BB962C8B-B14F-4D97-AF65-F5344CB8AC3E}">
@@ -18378,71 +17279,6 @@
           <a:chExt cx="0" cy="0"/>
         </a:xfrm>
       </p:grpSpPr>
-      <p:pic>
-        <p:nvPicPr>
-          <p:cNvPr id="10" name="Image 0" descr="/tmp/certops-slides/screenshots/homepage.png">
-            <a:extLst>
-              <a:ext uri="{FF2B5EF4-FFF2-40B4-BE49-F238E27FC236}">
-                <a16:creationId xmlns:a16="http://schemas.microsoft.com/office/drawing/2014/main" id="{AD8DF6D9-9172-4468-9FBC-D9A62497CC86}"/>
-              </a:ext>
-            </a:extLst>
-          </p:cNvPr>
-          <p:cNvPicPr>
-            <a:picLocks noChangeAspect="1"/>
-          </p:cNvPicPr>
-          <p:nvPr/>
-        </p:nvPicPr>
-        <p:blipFill>
-          <a:blip r:embed="rId3"/>
-          <a:srcRect l="17298" t="29706" r="17441" b="42067"/>
-          <a:stretch>
-            <a:fillRect/>
-          </a:stretch>
-        </p:blipFill>
-        <p:spPr>
-          <a:xfrm>
-            <a:off x="2065662" y="3402835"/>
-            <a:ext cx="5012675" cy="1355076"/>
-          </a:xfrm>
-          <a:prstGeom prst="rect">
-            <a:avLst/>
-          </a:prstGeom>
-          <a:effectLst>
-            <a:softEdge rad="63500"/>
-          </a:effectLst>
-        </p:spPr>
-      </p:pic>
-      <p:pic>
-        <p:nvPicPr>
-          <p:cNvPr id="12" name="Picture 11">
-            <a:extLst>
-              <a:ext uri="{FF2B5EF4-FFF2-40B4-BE49-F238E27FC236}">
-                <a16:creationId xmlns:a16="http://schemas.microsoft.com/office/drawing/2014/main" id="{B0AD99A7-EB42-97AD-DD87-6F6A9D8219D2}"/>
-              </a:ext>
-            </a:extLst>
-          </p:cNvPr>
-          <p:cNvPicPr>
-            <a:picLocks noChangeAspect="1"/>
-          </p:cNvPicPr>
-          <p:nvPr/>
-        </p:nvPicPr>
-        <p:blipFill>
-          <a:blip r:embed="rId4"/>
-          <a:srcRect l="10858" r="17754"/>
-          <a:stretch>
-            <a:fillRect/>
-          </a:stretch>
-        </p:blipFill>
-        <p:spPr>
-          <a:xfrm>
-            <a:off x="0" y="-246993"/>
-            <a:ext cx="8360206" cy="3954747"/>
-          </a:xfrm>
-          <a:prstGeom prst="rect">
-            <a:avLst/>
-          </a:prstGeom>
-        </p:spPr>
-      </p:pic>
     </p:spTree>
     <p:extLst>
       <p:ext uri="{BB962C8B-B14F-4D97-AF65-F5344CB8AC3E}">

</xml_diff>